<commit_message>
Humanize deck copy: plain team voice, no em dashes
Rewrote every slide line in first-person team language, removed all
em dashes and slogan-style phrasing, replaced prose arrows with words,
and renamed jargon labels (playbook, thesis, whitespace) to plain ones.
Layout, design and numbers unchanged.

Co-Authored-By: Claude Fable 5 <noreply@anthropic.com>
Claude-Session: https://claude.ai/code/session_01Ai1CqVaPZphmcqqjbJPmEX
</commit_message>
<xml_diff>
--- a/case-consilium/CaseConsilium_Wookies.pptx
+++ b/case-consilium/CaseConsilium_Wookies.pptx
@@ -2828,7 +2828,7 @@
                 <a:ea typeface="Arial" pitchFamily="34" charset="-122"/>
                 <a:cs typeface="Arial" pitchFamily="34" charset="-120"/>
               </a:rPr>
-              <a:t>private-pay TAM, 3 states</a:t>
+              <a:t>of private demand across 3 states</a:t>
             </a:r>
             <a:endParaRPr lang="en-US" sz="780" dirty="0"/>
           </a:p>
@@ -2967,7 +2967,7 @@
                 <a:ea typeface="Arial" pitchFamily="34" charset="-122"/>
                 <a:cs typeface="Arial" pitchFamily="34" charset="-120"/>
               </a:rPr>
-              <a:t>one 250 km service corridor</a:t>
+              <a:t>hotels, developers, hospitals</a:t>
             </a:r>
             <a:endParaRPr lang="en-US" sz="780" dirty="0"/>
           </a:p>
@@ -3106,7 +3106,7 @@
                 <a:ea typeface="Arial" pitchFamily="34" charset="-122"/>
                 <a:cs typeface="Arial" pitchFamily="34" charset="-120"/>
               </a:rPr>
-              <a:t>FY29 revenue, 2.2× FY26</a:t>
+              <a:t>revenue we target by FY29</a:t>
             </a:r>
             <a:endParaRPr lang="en-US" sz="780" dirty="0"/>
           </a:p>
@@ -3333,7 +3333,7 @@
                 <a:ea typeface="Arial" pitchFamily="34" charset="-122"/>
                 <a:cs typeface="Arial" pitchFamily="34" charset="-120"/>
               </a:rPr>
-              <a:t>Concentrate to Conquer
+              <a:t>How EPBL wins the
 </a:t>
             </a:r>
             <a:pPr indent="0" marL="0">
@@ -3351,7 +3351,7 @@
                 <a:ea typeface="Arial" pitchFamily="34" charset="-122"/>
                 <a:cs typeface="Arial" pitchFamily="34" charset="-120"/>
               </a:rPr>
-              <a:t>the Private Wastewater Market</a:t>
+              <a:t>private wastewater market</a:t>
             </a:r>
             <a:endParaRPr lang="en-US" sz="3400" dirty="0"/>
           </a:p>
@@ -3415,7 +3415,7 @@
                 <a:ea typeface="Arial" pitchFamily="34" charset="-122"/>
                 <a:cs typeface="Arial" pitchFamily="34" charset="-120"/>
               </a:rPr>
-              <a:t>Three compliance-driven buyers, one west-coast service corridor: ₹11.7 crore → ₹25.4 crore by FY29 on DRDO-certified bio-digesters, FRP modular STPs and recurring service revenue.</a:t>
+              <a:t>Sell to the three buyers who are forced to treat their wastewater, start close to home, and let service income compound. That takes EPBL from ₹11.7 crore today to about ₹25 crore by FY29.</a:t>
             </a:r>
             <a:endParaRPr lang="en-US" sz="1300" dirty="0"/>
           </a:p>
@@ -4252,7 +4252,7 @@
                 <a:ea typeface="Arial" pitchFamily="34" charset="-122"/>
                 <a:cs typeface="Arial" pitchFamily="34" charset="-120"/>
               </a:rPr>
-              <a:t>FY29 revenue, base case (cons ₹22.1 / up ₹29.3)</a:t>
+              <a:t>FY29 revenue in our base case (low ₹22.1, high ₹29.3)</a:t>
             </a:r>
             <a:endParaRPr lang="en-US" sz="800" dirty="0"/>
           </a:p>
@@ -4291,7 +4291,7 @@
                 <a:ea typeface="Arial" pitchFamily="34" charset="-122"/>
                 <a:cs typeface="Arial" pitchFamily="34" charset="-120"/>
               </a:rPr>
-              <a:t>2.2× the FY26 base of ₹11.7 cr</a:t>
+              <a:t>2.2x the FY26 base of ₹11.7 cr</a:t>
             </a:r>
             <a:endParaRPr lang="en-US" sz="800" dirty="0"/>
           </a:p>
@@ -4452,7 +4452,7 @@
                 <a:ea typeface="Arial" pitchFamily="34" charset="-122"/>
                 <a:cs typeface="Arial" pitchFamily="34" charset="-120"/>
               </a:rPr>
-              <a:t>cumulative NEW private-market revenue, FY27-29</a:t>
+              <a:t>of new private-market revenue added over FY27-29</a:t>
             </a:r>
             <a:endParaRPr lang="en-US" sz="800" dirty="0"/>
           </a:p>
@@ -4491,7 +4491,7 @@
                 <a:ea typeface="Arial" pitchFamily="34" charset="-122"/>
                 <a:cs typeface="Arial" pitchFamily="34" charset="-120"/>
               </a:rPr>
-              <a:t>range ₹15-28 cr across scenarios</a:t>
+              <a:t>₹15-28 cr depending on scenario</a:t>
             </a:r>
             <a:endParaRPr lang="en-US" sz="800" dirty="0"/>
           </a:p>
@@ -4652,7 +4652,7 @@
                 <a:ea typeface="Arial" pitchFamily="34" charset="-122"/>
                 <a:cs typeface="Arial" pitchFamily="34" charset="-120"/>
               </a:rPr>
-              <a:t>share of ₹165 cr/yr serviceable demand by FY29</a:t>
+              <a:t>of the ₹165 cr/yr serviceable market held by FY29</a:t>
             </a:r>
             <a:endParaRPr lang="en-US" sz="800" dirty="0"/>
           </a:p>
@@ -4691,7 +4691,7 @@
                 <a:ea typeface="Arial" pitchFamily="34" charset="-122"/>
                 <a:cs typeface="Arial" pitchFamily="34" charset="-120"/>
               </a:rPr>
-              <a:t>from ~0% today</a:t>
+              <a:t>starting from roughly zero today</a:t>
             </a:r>
             <a:endParaRPr lang="en-US" sz="800" dirty="0"/>
           </a:p>
@@ -4852,7 +4852,7 @@
                 <a:ea typeface="Arial" pitchFamily="34" charset="-122"/>
                 <a:cs typeface="Arial" pitchFamily="34" charset="-120"/>
               </a:rPr>
-              <a:t>recurring AMC, O&amp;M and monitoring revenue</a:t>
+              <a:t>comes back yearly from AMC, O&amp;M and monitoring</a:t>
             </a:r>
             <a:endParaRPr lang="en-US" sz="800" dirty="0"/>
           </a:p>
@@ -4891,7 +4891,7 @@
                 <a:ea typeface="Arial" pitchFamily="34" charset="-122"/>
                 <a:cs typeface="Arial" pitchFamily="34" charset="-120"/>
               </a:rPr>
-              <a:t>~10% of FY29 sales</a:t>
+              <a:t>about 10% of FY29 sales</a:t>
             </a:r>
             <a:endParaRPr lang="en-US" sz="800" dirty="0"/>
           </a:p>
@@ -5010,7 +5010,7 @@
                 <a:ea typeface="Arial" pitchFamily="34" charset="-122"/>
                 <a:cs typeface="Arial" pitchFamily="34" charset="-120"/>
               </a:rPr>
-              <a:t>The play in 5 moves</a:t>
+              <a:t>Our plan in five steps</a:t>
             </a:r>
             <a:endParaRPr lang="en-US" sz="1300" dirty="0"/>
           </a:p>
@@ -5113,7 +5113,7 @@
                 <a:ea typeface="Arial" pitchFamily="34" charset="-122"/>
                 <a:cs typeface="Arial" pitchFamily="34" charset="-120"/>
               </a:rPr>
-              <a:t>Prioritise 3 compliance-triggered buyers: hoteliers, Tier-2 developers, private hospitals</a:t>
+              <a:t>Sell to the buyers who have no choice: hotels, Tier-2 developers and private hospitals</a:t>
             </a:r>
             <a:endParaRPr lang="en-US" sz="830" dirty="0"/>
           </a:p>
@@ -5216,7 +5216,7 @@
                 <a:ea typeface="Arial" pitchFamily="34" charset="-122"/>
                 <a:cs typeface="Arial" pitchFamily="34" charset="-120"/>
               </a:rPr>
-              <a:t>Start in Goa + the 250 km corridor; expand ONLY through KPI gates</a:t>
+              <a:t>Start in Goa and towns within a day's drive; enter new cities only after old ones hit their targets</a:t>
             </a:r>
             <a:endParaRPr lang="en-US" sz="830" dirty="0"/>
           </a:p>
@@ -5319,7 +5319,7 @@
                 <a:ea typeface="Arial" pitchFamily="34" charset="-122"/>
                 <a:cs typeface="Arial" pitchFamily="34" charset="-120"/>
               </a:rPr>
-              <a:t>Sell ₹25k audits → standard 10/25/50/100 KLD FRP packages, milestone-billed</a:t>
+              <a:t>Open doors with a ₹25k site audit, then sell standard 10/25/50/100 KLD packages billed by milestone</a:t>
             </a:r>
             <a:endParaRPr lang="en-US" sz="830" dirty="0"/>
           </a:p>
@@ -5422,7 +5422,7 @@
                 <a:ea typeface="Arial" pitchFamily="34" charset="-122"/>
                 <a:cs typeface="Arial" pitchFamily="34" charset="-120"/>
               </a:rPr>
-              <a:t>Attach AMC to ≥60% of installs; add IoT monitoring for consent-ready data</a:t>
+              <a:t>Put AMC on at least 60% of installs, with IoT monitoring so clients clear consent renewals</a:t>
             </a:r>
             <a:endParaRPr lang="en-US" sz="830" dirty="0"/>
           </a:p>
@@ -5525,7 +5525,7 @@
                 <a:ea typeface="Arial" pitchFamily="34" charset="-122"/>
                 <a:cs typeface="Arial" pitchFamily="34" charset="-120"/>
               </a:rPr>
-              <a:t>Extend the installed base: retrofit &amp; O&amp;M, monitoring, water reuse (IISc)</a:t>
+              <a:t>Grow from the installed base: fix broken STPs, monitor them, then recycle their water (with IISc)</a:t>
             </a:r>
             <a:endParaRPr lang="en-US" sz="830" dirty="0"/>
           </a:p>
@@ -5644,7 +5644,7 @@
                 <a:ea typeface="Arial" pitchFamily="34" charset="-122"/>
                 <a:cs typeface="Arial" pitchFamily="34" charset="-120"/>
               </a:rPr>
-              <a:t>Priority personas (weighted score)</a:t>
+              <a:t>Who we go after first (weighted score)</a:t>
             </a:r>
             <a:endParaRPr lang="en-US" sz="1200" dirty="0"/>
           </a:p>
@@ -5871,7 +5871,7 @@
                 <a:ea typeface="Arial" pitchFamily="34" charset="-122"/>
                 <a:cs typeface="Arial" pitchFamily="34" charset="-120"/>
               </a:rPr>
-              <a:t>Trigger: PCB consent, expansion, water cost</a:t>
+              <a:t>Buys when PCB consent or water bills bite</a:t>
             </a:r>
             <a:endParaRPr lang="en-US" sz="760" dirty="0"/>
           </a:p>
@@ -6098,7 +6098,7 @@
                 <a:ea typeface="Arial" pitchFamily="34" charset="-122"/>
                 <a:cs typeface="Arial" pitchFamily="34" charset="-120"/>
               </a:rPr>
-              <a:t>Trigger: EC condition &amp; occupancy certificate</a:t>
+              <a:t>Needs a working STP to get the occupancy certificate</a:t>
             </a:r>
             <a:endParaRPr lang="en-US" sz="760" dirty="0"/>
           </a:p>
@@ -6325,7 +6325,7 @@
                 <a:ea typeface="Arial" pitchFamily="34" charset="-122"/>
                 <a:cs typeface="Arial" pitchFamily="34" charset="-120"/>
               </a:rPr>
-              <a:t>Trigger: BMW Rules &gt;10-bed ETP mandate</a:t>
+              <a:t>BMW Rules make treatment compulsory above 10 beds</a:t>
             </a:r>
             <a:endParaRPr lang="en-US" sz="760" dirty="0"/>
           </a:p>
@@ -6444,7 +6444,7 @@
                 <a:ea typeface="Arial" pitchFamily="34" charset="-122"/>
                 <a:cs typeface="Arial" pitchFamily="34" charset="-120"/>
               </a:rPr>
-              <a:t>Corridor sequencing</a:t>
+              <a:t>Where, and in what order</a:t>
             </a:r>
             <a:endParaRPr lang="en-US" sz="1200" dirty="0"/>
           </a:p>
@@ -6547,7 +6547,7 @@
                 <a:ea typeface="Arial" pitchFamily="34" charset="-122"/>
                 <a:cs typeface="Arial" pitchFamily="34" charset="-120"/>
               </a:rPr>
-              <a:t>Goa + Konkan, Kolhapur, Belagavi (≤250 km)</a:t>
+              <a:t>Goa plus Konkan, Kolhapur, Belagavi (within 250 km)</a:t>
             </a:r>
             <a:endParaRPr lang="en-US" sz="800" dirty="0"/>
           </a:p>
@@ -6650,7 +6650,7 @@
                 <a:ea typeface="Arial" pitchFamily="34" charset="-122"/>
                 <a:cs typeface="Arial" pitchFamily="34" charset="-120"/>
               </a:rPr>
-              <a:t>Hubballi-Dharwad, Mangaluru, Mysuru + hubs</a:t>
+              <a:t>Hubballi-Dharwad, Mangaluru, Mysuru, with 2 hubs</a:t>
             </a:r>
             <a:endParaRPr lang="en-US" sz="800" dirty="0"/>
           </a:p>
@@ -6753,7 +6753,7 @@
                 <a:ea typeface="Arial" pitchFamily="34" charset="-122"/>
                 <a:cs typeface="Arial" pitchFamily="34" charset="-120"/>
               </a:rPr>
-              <a:t>Tier-3 depth via 25 certified partners</a:t>
+              <a:t>Deeper Tier-3 towns through 25 trained partners</a:t>
             </a:r>
             <a:endParaRPr lang="en-US" sz="800" dirty="0"/>
           </a:p>
@@ -6872,7 +6872,7 @@
                 <a:ea typeface="Arial" pitchFamily="34" charset="-122"/>
                 <a:cs typeface="Arial" pitchFamily="34" charset="-120"/>
               </a:rPr>
-              <a:t>Biggest execution risk</a:t>
+              <a:t>The risk that worries us most</a:t>
             </a:r>
             <a:endParaRPr lang="en-US" sz="1200" dirty="0"/>
           </a:p>
@@ -6914,7 +6914,7 @@
                 <a:ea typeface="Arial" pitchFamily="34" charset="-122"/>
                 <a:cs typeface="Arial" pitchFamily="34" charset="-120"/>
               </a:rPr>
-              <a:t>Developer receivables straining working capital. </a:t>
+              <a:t>Developers paying late and locking up working capital. </a:t>
             </a:r>
             <a:pPr indent="0" marL="0">
               <a:lnSpc>
@@ -6931,7 +6931,7 @@
                 <a:ea typeface="Arial" pitchFamily="34" charset="-122"/>
                 <a:cs typeface="Arial" pitchFamily="34" charset="-120"/>
               </a:rPr>
-              <a:t>Controls: 30-40-25-5 milestone billing with advances, credit checks + PDCs, exposure cap 25% of order book, expansion stops if DSO &gt;75 days.</a:t>
+              <a:t>Our guardrails: 30-40-25-5 milestone billing with an advance, credit checks with PDCs, developers capped at 25% of the order book, and no new city if DSO crosses 75 days.</a:t>
             </a:r>
             <a:endParaRPr lang="en-US" sz="820" dirty="0"/>
           </a:p>
@@ -7026,7 +7026,7 @@
                 <a:ea typeface="Arial" pitchFamily="34" charset="-122"/>
                 <a:cs typeface="Arial" pitchFamily="34" charset="-120"/>
               </a:rPr>
-              <a:t>FY29 EXIT   </a:t>
+              <a:t>BY FY29   </a:t>
             </a:r>
             <a:pPr indent="0" marL="0">
               <a:lnSpc>
@@ -7035,7 +7035,7 @@
               <a:buNone/>
             </a:pPr>
             <a:r>
-              <a:rPr lang="en-US" sz="1150" b="1" dirty="0">
+              <a:rPr lang="en-US" sz="1100" b="1" dirty="0">
                 <a:solidFill>
                   <a:srgbClr val="FFFFFF"/>
                 </a:solidFill>
@@ -7043,7 +7043,7 @@
                 <a:ea typeface="Arial" pitchFamily="34" charset="-122"/>
                 <a:cs typeface="Arial" pitchFamily="34" charset="-120"/>
               </a:rPr>
-              <a:t>66 treatment projects + 400 bio-digesters delivered · 14 clusters via 2 hubs &amp; 25 partners · ~₹6 cr investment, fully self-funded</a:t>
+              <a:t>66 treatment projects and 400-plus bio-digesters, 14 clusters via 2 hubs and 25 partners, about ₹6 cr of self-funded spend</a:t>
             </a:r>
             <a:endParaRPr lang="en-US" sz="1000" dirty="0"/>
           </a:p>
@@ -7293,7 +7293,7 @@
                 <a:ea typeface="Arial" pitchFamily="34" charset="-122"/>
                 <a:cs typeface="Arial" pitchFamily="34" charset="-120"/>
               </a:rPr>
-              <a:t>Eight segments, </a:t>
+              <a:t>Eight buyer groups scored: </a:t>
             </a:r>
             <a:pPr indent="0" marL="0">
               <a:buNone/>
@@ -7307,7 +7307,7 @@
                 <a:ea typeface="Arial" pitchFamily="34" charset="-122"/>
                 <a:cs typeface="Arial" pitchFamily="34" charset="-120"/>
               </a:rPr>
-              <a:t>three worth pursuing</a:t>
+              <a:t>three worth chasing</a:t>
             </a:r>
             <a:endParaRPr lang="en-US" sz="2500" dirty="0"/>
           </a:p>
@@ -7506,7 +7506,7 @@
                 <a:ea typeface="Arial" pitchFamily="34" charset="-122"/>
                 <a:cs typeface="Arial" pitchFamily="34" charset="-120"/>
               </a:rPr>
-              <a:t>10-factor weighted attractiveness</a:t>
+              <a:t>How we scored them (10 factors)</a:t>
             </a:r>
             <a:endParaRPr lang="en-US" sz="1250" dirty="0"/>
           </a:p>
@@ -8311,7 +8311,7 @@
                 <a:ea typeface="Arial" pitchFamily="34" charset="-122"/>
                 <a:cs typeface="Arial" pitchFamily="34" charset="-120"/>
               </a:rPr>
-              <a:t>demand 15 · urgency 15 · fit 10 · ticket 10 · DM access 10 · payment 10 · repeat/AMC 10 · service 10 · rivalry 5 · cycle 5  (scores 1-5, backup p.9)</a:t>
+              <a:t>demand 15 · urgency 15 · fit 10 · ticket 10 · access to decision maker 10 · payment 10 · repeat/AMC 10 · service reach 10 · rivalry 5 · cycle 5  (scored 1 to 5, detail on p.9)</a:t>
             </a:r>
             <a:endParaRPr lang="en-US" sz="700" dirty="0"/>
           </a:p>
@@ -8396,7 +8396,7 @@
                 <a:ea typeface="Arial" pitchFamily="34" charset="-122"/>
                 <a:cs typeface="Arial" pitchFamily="34" charset="-120"/>
               </a:rPr>
-              <a:t>Priority persona playbook</a:t>
+              <a:t>The three buyers, up close</a:t>
             </a:r>
             <a:endParaRPr lang="en-US" sz="1250" dirty="0"/>
           </a:p>
@@ -8688,7 +8688,7 @@
                 <a:ea typeface="Arial" pitchFamily="34" charset="-122"/>
                 <a:cs typeface="Arial" pitchFamily="34" charset="-120"/>
               </a:rPr>
-              <a:t>TRIGGER  </a:t>
+              <a:t>WHY NOW  </a:t>
             </a:r>
             <a:pPr indent="0" marL="0">
               <a:lnSpc>
@@ -8705,7 +8705,7 @@
                 <a:ea typeface="Arial" pitchFamily="34" charset="-122"/>
                 <a:cs typeface="Arial" pitchFamily="34" charset="-120"/>
               </a:rPr>
-              <a:t>PCB consent renewal, expansion, tanker-water cost</a:t>
+              <a:t>Consent renewal due, property expanding, or tanker bills hurting</a:t>
             </a:r>
             <a:endParaRPr lang="en-US" sz="660" dirty="0"/>
           </a:p>
@@ -8771,7 +8771,7 @@
                 <a:ea typeface="Arial" pitchFamily="34" charset="-122"/>
                 <a:cs typeface="Arial" pitchFamily="34" charset="-120"/>
               </a:rPr>
-              <a:t>DECIDES  </a:t>
+              <a:t>WHO SIGNS  </a:t>
             </a:r>
             <a:pPr indent="0" marL="0">
               <a:lnSpc>
@@ -8788,7 +8788,7 @@
                 <a:ea typeface="Arial" pitchFamily="34" charset="-122"/>
                 <a:cs typeface="Arial" pitchFamily="34" charset="-120"/>
               </a:rPr>
-              <a:t>Owner-promoter; GM + MEP consultant influence</a:t>
+              <a:t>The owner; GM and MEP consultant weigh in</a:t>
             </a:r>
             <a:endParaRPr lang="en-US" sz="660" dirty="0"/>
           </a:p>
@@ -8854,7 +8854,7 @@
                 <a:ea typeface="Arial" pitchFamily="34" charset="-122"/>
                 <a:cs typeface="Arial" pitchFamily="34" charset="-120"/>
               </a:rPr>
-              <a:t>PRICE  </a:t>
+              <a:t>BUDGET  </a:t>
             </a:r>
             <a:pPr indent="0" marL="0">
               <a:lnSpc>
@@ -8871,7 +8871,7 @@
                 <a:ea typeface="Arial" pitchFamily="34" charset="-122"/>
                 <a:cs typeface="Arial" pitchFamily="34" charset="-120"/>
               </a:rPr>
-              <a:t>₹18-45 L turnkey + AMC ₹0.6-1.5 L/yr</a:t>
+              <a:t>₹18-45 L turnkey plus AMC of ₹0.6-1.5 L a year</a:t>
             </a:r>
             <a:endParaRPr lang="en-US" sz="660" dirty="0"/>
           </a:p>
@@ -8937,7 +8937,7 @@
                 <a:ea typeface="Arial" pitchFamily="34" charset="-122"/>
                 <a:cs typeface="Arial" pitchFamily="34" charset="-120"/>
               </a:rPr>
-              <a:t>CYCLE  </a:t>
+              <a:t>TIMELINE  </a:t>
             </a:r>
             <a:pPr indent="0" marL="0">
               <a:lnSpc>
@@ -8954,7 +8954,7 @@
                 <a:ea typeface="Arial" pitchFamily="34" charset="-122"/>
                 <a:cs typeface="Arial" pitchFamily="34" charset="-120"/>
               </a:rPr>
-              <a:t>2-4 months</a:t>
+              <a:t>2 to 4 months</a:t>
             </a:r>
             <a:endParaRPr lang="en-US" sz="660" dirty="0"/>
           </a:p>
@@ -9037,7 +9037,7 @@
                 <a:ea typeface="Arial" pitchFamily="34" charset="-122"/>
                 <a:cs typeface="Arial" pitchFamily="34" charset="-120"/>
               </a:rPr>
-              <a:t>Local reference visits, NABL lab reports, DRDO tech</a:t>
+              <a:t>A hotel they can visit, NABL lab reports, DRDO pedigree</a:t>
             </a:r>
             <a:endParaRPr lang="en-US" sz="660" dirty="0"/>
           </a:p>
@@ -9103,7 +9103,7 @@
                 <a:ea typeface="Arial" pitchFamily="34" charset="-122"/>
                 <a:cs typeface="Arial" pitchFamily="34" charset="-120"/>
               </a:rPr>
-              <a:t>ENTRY  </a:t>
+              <a:t>WAY IN  </a:t>
             </a:r>
             <a:pPr indent="0" marL="0">
               <a:lnSpc>
@@ -9120,7 +9120,7 @@
                 <a:ea typeface="Arial" pitchFamily="34" charset="-122"/>
                 <a:cs typeface="Arial" pitchFamily="34" charset="-120"/>
               </a:rPr>
-              <a:t>₹25k audit credited to order; install ≤4 weeks</a:t>
+              <a:t>₹25k audit, adjusted against the order; install inside 4 weeks</a:t>
             </a:r>
             <a:endParaRPr lang="en-US" sz="660" dirty="0"/>
           </a:p>
@@ -9203,7 +9203,7 @@
                 <a:ea typeface="Arial" pitchFamily="34" charset="-122"/>
                 <a:cs typeface="Arial" pitchFamily="34" charset="-120"/>
               </a:rPr>
-              <a:t>Sister properties, reuse-module upsell, consumables</a:t>
+              <a:t>Sister properties, reuse add-on, consumables</a:t>
             </a:r>
             <a:endParaRPr lang="en-US" sz="660" dirty="0"/>
           </a:p>
@@ -9495,7 +9495,7 @@
                 <a:ea typeface="Arial" pitchFamily="34" charset="-122"/>
                 <a:cs typeface="Arial" pitchFamily="34" charset="-120"/>
               </a:rPr>
-              <a:t>TRIGGER  </a:t>
+              <a:t>WHY NOW  </a:t>
             </a:r>
             <a:pPr indent="0" marL="0">
               <a:lnSpc>
@@ -9512,7 +9512,7 @@
                 <a:ea typeface="Arial" pitchFamily="34" charset="-122"/>
                 <a:cs typeface="Arial" pitchFamily="34" charset="-120"/>
               </a:rPr>
-              <a:t>EC ≥20,000 sqm &amp; occupancy certificate need live STP</a:t>
+              <a:t>EC terms and the occupancy certificate demand a live STP</a:t>
             </a:r>
             <a:endParaRPr lang="en-US" sz="660" dirty="0"/>
           </a:p>
@@ -9578,7 +9578,7 @@
                 <a:ea typeface="Arial" pitchFamily="34" charset="-122"/>
                 <a:cs typeface="Arial" pitchFamily="34" charset="-120"/>
               </a:rPr>
-              <a:t>DECIDES  </a:t>
+              <a:t>WHO SIGNS  </a:t>
             </a:r>
             <a:pPr indent="0" marL="0">
               <a:lnSpc>
@@ -9595,7 +9595,7 @@
                 <a:ea typeface="Arial" pitchFamily="34" charset="-122"/>
                 <a:cs typeface="Arial" pitchFamily="34" charset="-120"/>
               </a:rPr>
-              <a:t>Promoter; MEP consultant + PMC specify</a:t>
+              <a:t>Promoter; MEP consultant and PMC write the spec</a:t>
             </a:r>
             <a:endParaRPr lang="en-US" sz="660" dirty="0"/>
           </a:p>
@@ -9661,7 +9661,7 @@
                 <a:ea typeface="Arial" pitchFamily="34" charset="-122"/>
                 <a:cs typeface="Arial" pitchFamily="34" charset="-120"/>
               </a:rPr>
-              <a:t>PRICE  </a:t>
+              <a:t>BUDGET  </a:t>
             </a:r>
             <a:pPr indent="0" marL="0">
               <a:lnSpc>
@@ -9678,7 +9678,7 @@
                 <a:ea typeface="Arial" pitchFamily="34" charset="-122"/>
                 <a:cs typeface="Arial" pitchFamily="34" charset="-120"/>
               </a:rPr>
-              <a:t>₹35 L-1.2 cr design-build, milestone billed</a:t>
+              <a:t>₹35 L to 1.2 cr design-build, billed by milestone</a:t>
             </a:r>
             <a:endParaRPr lang="en-US" sz="660" dirty="0"/>
           </a:p>
@@ -9744,7 +9744,7 @@
                 <a:ea typeface="Arial" pitchFamily="34" charset="-122"/>
                 <a:cs typeface="Arial" pitchFamily="34" charset="-120"/>
               </a:rPr>
-              <a:t>CYCLE  </a:t>
+              <a:t>TIMELINE  </a:t>
             </a:r>
             <a:pPr indent="0" marL="0">
               <a:lnSpc>
@@ -9761,7 +9761,7 @@
                 <a:ea typeface="Arial" pitchFamily="34" charset="-122"/>
                 <a:cs typeface="Arial" pitchFamily="34" charset="-120"/>
               </a:rPr>
-              <a:t>6-9 months (tracks construction)</a:t>
+              <a:t>6 to 9 months, moving with construction</a:t>
             </a:r>
             <a:endParaRPr lang="en-US" sz="660" dirty="0"/>
           </a:p>
@@ -9844,7 +9844,7 @@
                 <a:ea typeface="Arial" pitchFamily="34" charset="-122"/>
                 <a:cs typeface="Arial" pitchFamily="34" charset="-120"/>
               </a:rPr>
-              <a:t>200+ housing installs, ONGC 100-KLD MBR, BG</a:t>
+              <a:t>200-plus housing installs, the ONGC 100 KLD job, bank guarantee</a:t>
             </a:r>
             <a:endParaRPr lang="en-US" sz="660" dirty="0"/>
           </a:p>
@@ -9910,7 +9910,7 @@
                 <a:ea typeface="Arial" pitchFamily="34" charset="-122"/>
                 <a:cs typeface="Arial" pitchFamily="34" charset="-120"/>
               </a:rPr>
-              <a:t>ENTRY  </a:t>
+              <a:t>WAY IN  </a:t>
             </a:r>
             <a:pPr indent="0" marL="0">
               <a:lnSpc>
@@ -9927,7 +9927,7 @@
                 <a:ea typeface="Arial" pitchFamily="34" charset="-122"/>
                 <a:cs typeface="Arial" pitchFamily="34" charset="-120"/>
               </a:rPr>
-              <a:t>Free sizing at EC stage; spec-in via consultant</a:t>
+              <a:t>Free STP sizing at EC stage so we get written into the spec</a:t>
             </a:r>
             <a:endParaRPr lang="en-US" sz="660" dirty="0"/>
           </a:p>
@@ -10010,7 +10010,7 @@
                 <a:ea typeface="Arial" pitchFamily="34" charset="-122"/>
                 <a:cs typeface="Arial" pitchFamily="34" charset="-120"/>
               </a:rPr>
-              <a:t>Next projects + society O&amp;M annuity post-handover</a:t>
+              <a:t>Their next project, plus society O&amp;M after handover</a:t>
             </a:r>
             <a:endParaRPr lang="en-US" sz="660" dirty="0"/>
           </a:p>
@@ -10302,7 +10302,7 @@
                 <a:ea typeface="Arial" pitchFamily="34" charset="-122"/>
                 <a:cs typeface="Arial" pitchFamily="34" charset="-120"/>
               </a:rPr>
-              <a:t>TRIGGER  </a:t>
+              <a:t>WHY NOW  </a:t>
             </a:r>
             <a:pPr indent="0" marL="0">
               <a:lnSpc>
@@ -10319,7 +10319,7 @@
                 <a:ea typeface="Arial" pitchFamily="34" charset="-122"/>
                 <a:cs typeface="Arial" pitchFamily="34" charset="-120"/>
               </a:rPr>
-              <a:t>BMW Rules &gt;10-bed ETP mandate, NABH, consent</a:t>
+              <a:t>BMW Rules apply above 10 beds; NABH and consent add pressure</a:t>
             </a:r>
             <a:endParaRPr lang="en-US" sz="660" dirty="0"/>
           </a:p>
@@ -10385,7 +10385,7 @@
                 <a:ea typeface="Arial" pitchFamily="34" charset="-122"/>
                 <a:cs typeface="Arial" pitchFamily="34" charset="-120"/>
               </a:rPr>
-              <a:t>DECIDES  </a:t>
+              <a:t>WHO SIGNS  </a:t>
             </a:r>
             <a:pPr indent="0" marL="0">
               <a:lnSpc>
@@ -10402,7 +10402,7 @@
                 <a:ea typeface="Arial" pitchFamily="34" charset="-122"/>
                 <a:cs typeface="Arial" pitchFamily="34" charset="-120"/>
               </a:rPr>
-              <a:t>Owner-doctor / trustee; administrator influences</a:t>
+              <a:t>Owner-doctor or trustee; the administrator runs the process</a:t>
             </a:r>
             <a:endParaRPr lang="en-US" sz="660" dirty="0"/>
           </a:p>
@@ -10468,7 +10468,7 @@
                 <a:ea typeface="Arial" pitchFamily="34" charset="-122"/>
                 <a:cs typeface="Arial" pitchFamily="34" charset="-120"/>
               </a:rPr>
-              <a:t>PRICE  </a:t>
+              <a:t>BUDGET  </a:t>
             </a:r>
             <a:pPr indent="0" marL="0">
               <a:lnSpc>
@@ -10485,7 +10485,7 @@
                 <a:ea typeface="Arial" pitchFamily="34" charset="-122"/>
                 <a:cs typeface="Arial" pitchFamily="34" charset="-120"/>
               </a:rPr>
-              <a:t>₹12-35 L compact skid + AMC ₹0.8-2 L/yr</a:t>
+              <a:t>₹12-35 L compact skid plus AMC of ₹0.8-2 L a year</a:t>
             </a:r>
             <a:endParaRPr lang="en-US" sz="660" dirty="0"/>
           </a:p>
@@ -10551,7 +10551,7 @@
                 <a:ea typeface="Arial" pitchFamily="34" charset="-122"/>
                 <a:cs typeface="Arial" pitchFamily="34" charset="-120"/>
               </a:rPr>
-              <a:t>CYCLE  </a:t>
+              <a:t>TIMELINE  </a:t>
             </a:r>
             <a:pPr indent="0" marL="0">
               <a:lnSpc>
@@ -10568,7 +10568,7 @@
                 <a:ea typeface="Arial" pitchFamily="34" charset="-122"/>
                 <a:cs typeface="Arial" pitchFamily="34" charset="-120"/>
               </a:rPr>
-              <a:t>3-6 months</a:t>
+              <a:t>3 to 6 months</a:t>
             </a:r>
             <a:endParaRPr lang="en-US" sz="660" dirty="0"/>
           </a:p>
@@ -10651,7 +10651,7 @@
                 <a:ea typeface="Arial" pitchFamily="34" charset="-122"/>
                 <a:cs typeface="Arial" pitchFamily="34" charset="-120"/>
               </a:rPr>
-              <a:t>Compliance document pack, live-site install method</a:t>
+              <a:t>Compliance file, and proof we can install without shutting wards</a:t>
             </a:r>
             <a:endParaRPr lang="en-US" sz="660" dirty="0"/>
           </a:p>
@@ -10717,7 +10717,7 @@
                 <a:ea typeface="Arial" pitchFamily="34" charset="-122"/>
                 <a:cs typeface="Arial" pitchFamily="34" charset="-120"/>
               </a:rPr>
-              <a:t>ENTRY  </a:t>
+              <a:t>WAY IN  </a:t>
             </a:r>
             <a:pPr indent="0" marL="0">
               <a:lnSpc>
@@ -10734,7 +10734,7 @@
                 <a:ea typeface="Arial" pitchFamily="34" charset="-122"/>
                 <a:cs typeface="Arial" pitchFamily="34" charset="-120"/>
               </a:rPr>
-              <a:t>Liquid-waste audit + PCB liaison support</a:t>
+              <a:t>Liquid-waste audit plus help dealing with the PCB</a:t>
             </a:r>
             <a:endParaRPr lang="en-US" sz="660" dirty="0"/>
           </a:p>
@@ -10817,7 +10817,7 @@
                 <a:ea typeface="Arial" pitchFamily="34" charset="-122"/>
                 <a:cs typeface="Arial" pitchFamily="34" charset="-120"/>
               </a:rPr>
-              <a:t>Sister facilities, disinfection upgrades, long AMC</a:t>
+              <a:t>Sister facilities, disinfection upgrades, long AMC stays</a:t>
             </a:r>
             <a:endParaRPr lang="en-US" sz="660" dirty="0"/>
           </a:p>
@@ -10912,7 +10912,7 @@
                 <a:ea typeface="Arial" pitchFamily="34" charset="-122"/>
                 <a:cs typeface="Arial" pitchFamily="34" charset="-120"/>
               </a:rPr>
-              <a:t>DECISION   </a:t>
+              <a:t>OUR CALL   </a:t>
             </a:r>
             <a:pPr indent="0" marL="0">
               <a:lnSpc>
@@ -10921,7 +10921,7 @@
               <a:buNone/>
             </a:pPr>
             <a:r>
-              <a:rPr lang="en-US" sz="1150" b="1" dirty="0">
+              <a:rPr lang="en-US" sz="1100" b="1" dirty="0">
                 <a:solidFill>
                   <a:srgbClr val="FFFFFF"/>
                 </a:solidFill>
@@ -10929,7 +10929,7 @@
                 <a:ea typeface="Arial" pitchFamily="34" charset="-122"/>
                 <a:cs typeface="Arial" pitchFamily="34" charset="-120"/>
               </a:rPr>
-              <a:t>80% of new-business effort on these three. Homeowners stay dealer-led run-rate; industrial ETPs opportunistic only.</a:t>
+              <a:t>Put 80% of new-business time on these three. Homeowners keep buying through dealers; industrial ETPs only when they come to us.</a:t>
             </a:r>
             <a:endParaRPr lang="en-US" sz="1000" dirty="0"/>
           </a:p>
@@ -11179,7 +11179,7 @@
                 <a:ea typeface="Arial" pitchFamily="34" charset="-122"/>
                 <a:cs typeface="Arial" pitchFamily="34" charset="-120"/>
               </a:rPr>
-              <a:t>A ₹270 cr/yr market; </a:t>
+              <a:t>A ₹270 cr a year market: </a:t>
             </a:r>
             <a:pPr indent="0" marL="0">
               <a:buNone/>
@@ -11193,7 +11193,7 @@
                 <a:ea typeface="Arial" pitchFamily="34" charset="-122"/>
                 <a:cs typeface="Arial" pitchFamily="34" charset="-120"/>
               </a:rPr>
-              <a:t>₹21 cr capture by FY29</a:t>
+              <a:t>we can take ₹21 cr of it</a:t>
             </a:r>
             <a:endParaRPr lang="en-US" sz="2500" dirty="0"/>
           </a:p>
@@ -11368,7 +11368,7 @@
         <p:spPr>
           <a:xfrm>
             <a:off x="841248" y="1293876"/>
-            <a:ext cx="3291840" cy="329184"/>
+            <a:ext cx="3383280" cy="329184"/>
           </a:xfrm>
           <a:prstGeom prst="rect">
             <a:avLst/>
@@ -11392,7 +11392,7 @@
                 <a:ea typeface="Arial" pitchFamily="34" charset="-122"/>
                 <a:cs typeface="Arial" pitchFamily="34" charset="-120"/>
               </a:rPr>
-              <a:t>Bottom-up sizing</a:t>
+              <a:t>Sized bottom-up, not from reports</a:t>
             </a:r>
             <a:endParaRPr lang="en-US" sz="1250" dirty="0"/>
           </a:p>
@@ -11709,7 +11709,7 @@
                 <a:ea typeface="Arial" pitchFamily="34" charset="-122"/>
                 <a:cs typeface="Arial" pitchFamily="34" charset="-120"/>
               </a:rPr>
-              <a:t>all private-pay Tier-2/3 demand, GA+MH+KA (₹239 cr STP/ETP + ₹32 cr bio)   </a:t>
+              <a:t>all private-pay Tier 2/3 demand in the 3 states (₹239 cr STP/ETP, ₹32 cr bio)   </a:t>
             </a:r>
             <a:pPr indent="0" marL="0">
               <a:lnSpc>
@@ -11760,7 +11760,7 @@
                 <a:ea typeface="Arial" pitchFamily="34" charset="-122"/>
                 <a:cs typeface="Arial" pitchFamily="34" charset="-120"/>
               </a:rPr>
-              <a:t>corridor + capability, ₹5 L-2.5 cr projects   </a:t>
+              <a:t>what our corridor and skills can serve, ₹5 L-2.5 cr jobs   </a:t>
             </a:r>
             <a:pPr indent="0" marL="0">
               <a:lnSpc>
@@ -11811,7 +11811,7 @@
                 <a:ea typeface="Arial" pitchFamily="34" charset="-122"/>
                 <a:cs typeface="Arial" pitchFamily="34" charset="-120"/>
               </a:rPr>
-              <a:t>3-yr cumulative NEW revenue (₹15-28 cr) = 7.2% of SAM by FY29</a:t>
+              <a:t>new revenue we add over FY27-29 (₹15-28 cr), 7.2% of SAM by FY29</a:t>
             </a:r>
             <a:endParaRPr lang="en-US" sz="680" dirty="0"/>
           </a:p>
@@ -12293,7 +12293,7 @@
                 <a:ea typeface="Arial" pitchFamily="34" charset="-122"/>
                 <a:cs typeface="Arial" pitchFamily="34" charset="-120"/>
               </a:rPr>
-              <a:t>Developers dominate value but pay slowly → </a:t>
+              <a:t>Developers are the biggest pool but pay slowly, so </a:t>
             </a:r>
             <a:pPr indent="0" marL="0">
               <a:lnSpc>
@@ -12310,7 +12310,7 @@
                 <a:ea typeface="Arial" pitchFamily="34" charset="-122"/>
                 <a:cs typeface="Arial" pitchFamily="34" charset="-120"/>
               </a:rPr>
-              <a:t>SOM tilts to hotels &amp; hospitals; developer exposure ≤25% of order book. </a:t>
+              <a:t>we lean on hotels and hospitals and cap developers at 25% of the book. </a:t>
             </a:r>
             <a:pPr indent="0" marL="0">
               <a:lnSpc>
@@ -12327,7 +12327,7 @@
                 <a:ea typeface="Arial" pitchFamily="34" charset="-122"/>
                 <a:cs typeface="Arial" pitchFamily="34" charset="-120"/>
               </a:rPr>
-              <a:t>Formula: units × %lacking × fit × conversion × ticket (p.9).</a:t>
+              <a:t>Formula: units x share lacking treatment x fit x conversion x ticket (p.9).</a:t>
             </a:r>
             <a:endParaRPr lang="en-US" sz="760" dirty="0"/>
           </a:p>
@@ -13606,7 +13606,7 @@
                 <a:ea typeface="Arial" pitchFamily="34" charset="-122"/>
                 <a:cs typeface="Arial" pitchFamily="34" charset="-120"/>
               </a:rPr>
-              <a:t>SWING FACTORS  </a:t>
+              <a:t>WHAT MOVES THE NUMBER  </a:t>
             </a:r>
             <a:pPr indent="0" marL="0">
               <a:lnSpc>
@@ -13623,7 +13623,7 @@
                 <a:ea typeface="Arial" pitchFamily="34" charset="-122"/>
                 <a:cs typeface="Arial" pitchFamily="34" charset="-120"/>
               </a:rPr>
-              <a:t>hotel conversion 6→10%/yr (±₹9 cr TAM); developer STP-trigger share 15→25% (±₹35 cr); proposal win-rate 15→25%.</a:t>
+              <a:t>hotel conversion between 6 and 10% a year (₹9 cr swing); developer STP-trigger share between 15 and 25% (₹35 cr); proposal win rate between 15 and 25%.</a:t>
             </a:r>
             <a:endParaRPr lang="en-US" sz="700" dirty="0"/>
           </a:p>
@@ -13689,7 +13689,7 @@
                 <a:ea typeface="Arial" pitchFamily="34" charset="-122"/>
                 <a:cs typeface="Arial" pitchFamily="34" charset="-120"/>
               </a:rPr>
-              <a:t>FY29 needs 34 installs/yr = 5 crews (3 own + 2 partner) — feasible</a:t>
+              <a:t>FY29 needs 34 installs a year; 5 crews (3 ours, 2 partner) can do it</a:t>
             </a:r>
             <a:endParaRPr lang="en-US" sz="760" dirty="0"/>
           </a:p>
@@ -13755,7 +13755,7 @@
                 <a:ea typeface="Arial" pitchFamily="34" charset="-122"/>
                 <a:cs typeface="Arial" pitchFamily="34" charset="-120"/>
               </a:rPr>
-              <a:t>Receivables @75 DSO = ₹5.2 cr vs net worth &gt;₹12 cr + IPO WC</a:t>
+              <a:t>At 75 receivable days, ₹5.2 cr is locked up, vs net worth above ₹12 cr</a:t>
             </a:r>
             <a:endParaRPr lang="en-US" sz="760" dirty="0"/>
           </a:p>
@@ -13821,7 +13821,7 @@
                 <a:ea typeface="Arial" pitchFamily="34" charset="-122"/>
                 <a:cs typeface="Arial" pitchFamily="34" charset="-120"/>
               </a:rPr>
-              <a:t>₹6.2 cr 3-yr investment funded from internal accruals</a:t>
+              <a:t>The ₹6.2 cr of investment over 3 years comes from internal accruals</a:t>
             </a:r>
             <a:endParaRPr lang="en-US" sz="760" dirty="0"/>
           </a:p>
@@ -13916,7 +13916,7 @@
                 <a:ea typeface="Arial" pitchFamily="34" charset="-122"/>
                 <a:cs typeface="Arial" pitchFamily="34" charset="-120"/>
               </a:rPr>
-              <a:t>POSITIONING   </a:t>
+              <a:t>OUR PITCH   </a:t>
             </a:r>
             <a:pPr indent="0" marL="0">
               <a:lnSpc>
@@ -13925,7 +13925,7 @@
               <a:buNone/>
             </a:pPr>
             <a:r>
-              <a:rPr lang="en-US" sz="1050" b="1" dirty="0">
+              <a:rPr lang="en-US" sz="1000" b="1" dirty="0">
                 <a:solidFill>
                   <a:srgbClr val="FFFFFF"/>
                 </a:solidFill>
@@ -13933,7 +13933,7 @@
                 <a:ea typeface="Arial" pitchFamily="34" charset="-122"/>
                 <a:cs typeface="Arial" pitchFamily="34" charset="-120"/>
               </a:rPr>
-              <a:t>The west-coast compliance partner: certified tech + in-state FRP + 24-48h service — sell lifecycle cost, not lowest capex.</a:t>
+              <a:t>The compliance partner next door: certified technology, FRP made in Goa, service within a day or two. We sell on lifetime cost, not the cheapest quote.</a:t>
             </a:r>
             <a:endParaRPr lang="en-US" sz="1000" dirty="0"/>
           </a:p>
@@ -15264,7 +15264,7 @@
                           <a:ea typeface="Arial" pitchFamily="34" charset="-122"/>
                           <a:cs typeface="Arial" pitchFamily="34" charset="-120"/>
                         </a:rPr>
-                        <a:t>SME → municipal, all scales</a:t>
+                        <a:t>SME up to municipal, all scales</a:t>
                       </a:r>
                       <a:endParaRPr lang="en-US" sz="650" dirty="0">
                         <a:latin typeface="Arial" charset="0"/>
@@ -15332,7 +15332,7 @@
                           <a:ea typeface="Arial" pitchFamily="34" charset="-122"/>
                           <a:cs typeface="Arial" pitchFamily="34" charset="-120"/>
                         </a:rPr>
-                        <a:t>Industrial; &gt;1 MLD EPC</a:t>
+                        <a:t>Industrial; above 1 MLD EPC</a:t>
                       </a:r>
                       <a:endParaRPr lang="en-US" sz="650" dirty="0">
                         <a:latin typeface="Arial" charset="0"/>
@@ -16131,7 +16131,7 @@
                           <a:ea typeface="Arial" pitchFamily="34" charset="-122"/>
                           <a:cs typeface="Arial" pitchFamily="34" charset="-120"/>
                         </a:rPr>
-                        <a:t>Whitespace for EPBL</a:t>
+                        <a:t>Gap EPBL can use</a:t>
                       </a:r>
                       <a:endParaRPr lang="en-US" sz="650" dirty="0">
                         <a:latin typeface="Arial" charset="0"/>
@@ -16199,7 +16199,7 @@
                           <a:ea typeface="Arial" pitchFamily="34" charset="-122"/>
                           <a:cs typeface="Arial" pitchFamily="34" charset="-120"/>
                         </a:rPr>
-                        <a:t>— defend with certification + service</a:t>
+                        <a:t>Ours to defend, with certification and service</a:t>
                       </a:r>
                       <a:endParaRPr lang="en-US" sz="650" dirty="0">
                         <a:latin typeface="Arial" charset="0"/>
@@ -16267,7 +16267,7 @@
                           <a:ea typeface="Arial" pitchFamily="34" charset="-122"/>
                           <a:cs typeface="Arial" pitchFamily="34" charset="-120"/>
                         </a:rPr>
-                        <a:t>Premium import; thin turnkey civil</a:t>
+                        <a:t>Premium import; thin turnkey civil work</a:t>
                       </a:r>
                       <a:endParaRPr lang="en-US" sz="650" dirty="0">
                         <a:latin typeface="Arial" charset="0"/>
@@ -16403,7 +16403,7 @@
                           <a:ea typeface="Arial" pitchFamily="34" charset="-122"/>
                           <a:cs typeface="Arial" pitchFamily="34" charset="-120"/>
                         </a:rPr>
-                        <a:t>10-50 KLD not a focus</a:t>
+                        <a:t>10-50 KLD is not their focus</a:t>
                       </a:r>
                       <a:endParaRPr lang="en-US" sz="650" dirty="0">
                         <a:latin typeface="Arial" charset="0"/>
@@ -16471,7 +16471,7 @@
                           <a:ea typeface="Arial" pitchFamily="34" charset="-122"/>
                           <a:cs typeface="Arial" pitchFamily="34" charset="-120"/>
                         </a:rPr>
-                        <a:t>Sharpest rival: beat on GA/KA service</a:t>
+                        <a:t>Toughest rival; beat them on Goa/KA service</a:t>
                       </a:r>
                       <a:endParaRPr lang="en-US" sz="650" dirty="0">
                         <a:latin typeface="Arial" charset="0"/>
@@ -16907,7 +16907,7 @@
                 <a:ea typeface="Arial" pitchFamily="34" charset="-122"/>
                 <a:cs typeface="Arial" pitchFamily="34" charset="-120"/>
               </a:rPr>
-              <a:t>36 months, </a:t>
+              <a:t>A 36-month rollout </a:t>
             </a:r>
             <a:pPr indent="0" marL="0">
               <a:buNone/>
@@ -16921,7 +16921,7 @@
                 <a:ea typeface="Arial" pitchFamily="34" charset="-122"/>
                 <a:cs typeface="Arial" pitchFamily="34" charset="-120"/>
               </a:rPr>
-              <a:t>gated corridor by corridor</a:t>
+              <a:t>that earns each next step</a:t>
             </a:r>
             <a:endParaRPr lang="en-US" sz="2500" dirty="0"/>
           </a:p>
@@ -17189,7 +17189,7 @@
                 <a:ea typeface="Arial" pitchFamily="34" charset="-122"/>
                 <a:cs typeface="Arial" pitchFamily="34" charset="-120"/>
               </a:rPr>
-              <a:t>Fortress Goa + Konkan  </a:t>
+              <a:t>Goa and the Konkan belt  </a:t>
             </a:r>
             <a:pPr indent="0" marL="0">
               <a:buNone/>
@@ -17535,7 +17535,7 @@
                 <a:ea typeface="Arial" pitchFamily="34" charset="-122"/>
                 <a:cs typeface="Arial" pitchFamily="34" charset="-120"/>
               </a:rPr>
-              <a:t>Founder-led ABM + 2 AMs; 15 MEP consultants; TTAG, GCCI, CREDAI Kolhapur; 10 dealers</a:t>
+              <a:t>Founder-led key accounts plus 2 salespeople; 15 MEP consultants; TTAG, GCCI, CREDAI Kolhapur; 10 dealers</a:t>
             </a:r>
             <a:endParaRPr lang="en-US" sz="660" dirty="0"/>
           </a:p>
@@ -17875,7 +17875,7 @@
                 <a:ea typeface="Arial" pitchFamily="34" charset="-122"/>
                 <a:cs typeface="Arial" pitchFamily="34" charset="-120"/>
               </a:rPr>
-              <a:t>Karnataka corridor  </a:t>
+              <a:t>Into Karnataka  </a:t>
             </a:r>
             <a:pPr indent="0" marL="0">
               <a:buNone/>
@@ -18561,7 +18561,7 @@
                 <a:ea typeface="Arial" pitchFamily="34" charset="-122"/>
                 <a:cs typeface="Arial" pitchFamily="34" charset="-120"/>
               </a:rPr>
-              <a:t>Tier-3 via partners  </a:t>
+              <a:t>Tier-3 through partners  </a:t>
             </a:r>
             <a:pPr indent="0" marL="0">
               <a:buNone/>
@@ -19849,7 +19849,7 @@
                 <a:ea typeface="Arial" pitchFamily="34" charset="-122"/>
                 <a:cs typeface="Arial" pitchFamily="34" charset="-120"/>
               </a:rPr>
-              <a:t>Cycle: hotels 2-4 mo · hospitals 3-6 mo · developers 6-9 mo   |   Crews: 2 own FY27 → 3 own + 2 partner FY29 (~8 installs/crew/yr)   |   KPIs: pipeline cover, proposal→win %, DSO, install cycle, AMC attach, uptime, repeat share</a:t>
+              <a:t>Cycle: hotels 2-4 mo · hospitals 3-6 mo · developers 6-9 mo   |   Crews: 2 of our own in FY27, growing to 3 own + 2 partner by FY29 (~8 installs per crew a year)   |   KPIs: pipeline cover, proposal-to-win %, DSO, install cycle, AMC attach, uptime, repeat share</a:t>
             </a:r>
             <a:endParaRPr lang="en-US" sz="690" dirty="0"/>
           </a:p>
@@ -20045,7 +20045,7 @@
                 <a:ea typeface="Arial" pitchFamily="34" charset="-122"/>
                 <a:cs typeface="Arial" pitchFamily="34" charset="-120"/>
               </a:rPr>
-              <a:t>RULE   </a:t>
+              <a:t>THE RULE   </a:t>
             </a:r>
             <a:pPr indent="0" marL="0">
               <a:lnSpc>
@@ -20054,7 +20054,7 @@
               <a:buNone/>
             </a:pPr>
             <a:r>
-              <a:rPr lang="en-US" sz="1150" b="1" dirty="0">
+              <a:rPr lang="en-US" sz="1100" b="1" dirty="0">
                 <a:solidFill>
                   <a:srgbClr val="FFFFFF"/>
                 </a:solidFill>
@@ -20062,7 +20062,7 @@
                 <a:ea typeface="Arial" pitchFamily="34" charset="-122"/>
                 <a:cs typeface="Arial" pitchFamily="34" charset="-120"/>
               </a:rPr>
-              <a:t>A new cluster opens only when the previous one passes its gate — service quality and cash discipline scale before geography.</a:t>
+              <a:t>We open a new city only after the last one passes its gate. Service quality and cash discipline grow first, geography second.</a:t>
             </a:r>
             <a:endParaRPr lang="en-US" sz="1000" dirty="0"/>
           </a:p>
@@ -20312,7 +20312,7 @@
                 <a:ea typeface="Arial" pitchFamily="34" charset="-122"/>
                 <a:cs typeface="Arial" pitchFamily="34" charset="-120"/>
               </a:rPr>
-              <a:t>Cash and credibility </a:t>
+              <a:t>What can go wrong, </a:t>
             </a:r>
             <a:pPr indent="0" marL="0">
               <a:buNone/>
@@ -20326,7 +20326,7 @@
                 <a:ea typeface="Arial" pitchFamily="34" charset="-122"/>
                 <a:cs typeface="Arial" pitchFamily="34" charset="-120"/>
               </a:rPr>
-              <a:t>are the binding constraints</a:t>
+              <a:t>and what we would do about it</a:t>
             </a:r>
             <a:endParaRPr lang="en-US" sz="2500" dirty="0"/>
           </a:p>
@@ -22529,7 +22529,7 @@
                 <a:ea typeface="Arial" pitchFamily="34" charset="-122"/>
                 <a:cs typeface="Arial" pitchFamily="34" charset="-120"/>
               </a:rPr>
-              <a:t>Mitigation playbook: six material risks</a:t>
+              <a:t>The six risks that matter, and our answers</a:t>
             </a:r>
             <a:endParaRPr lang="en-US" sz="1250" dirty="0"/>
           </a:p>
@@ -24953,7 +24953,7 @@
                           <a:ea typeface="Arial" pitchFamily="34" charset="-122"/>
                           <a:cs typeface="Arial" pitchFamily="34" charset="-120"/>
                         </a:rPr>
-                        <a:t>R6 Norms tighten (Regulatory — added)</a:t>
+                        <a:t>R6 Norms tighten (Regulatory, our added category)</a:t>
                       </a:r>
                       <a:endParaRPr lang="en-US" sz="720" dirty="0">
                         <a:latin typeface="Arial" charset="0"/>
@@ -25437,7 +25437,7 @@
                 <a:ea typeface="Arial" pitchFamily="34" charset="-122"/>
                 <a:cs typeface="Arial" pitchFamily="34" charset="-120"/>
               </a:rPr>
-              <a:t>Watch metrics for the two monitored risks</a:t>
+              <a:t>The two risks we watch rather than fix upfront</a:t>
             </a:r>
             <a:endParaRPr lang="en-US" sz="1150" dirty="0"/>
           </a:p>
@@ -25496,7 +25496,7 @@
                 <a:ea typeface="Arial" pitchFamily="34" charset="-122"/>
                 <a:cs typeface="Arial" pitchFamily="34" charset="-120"/>
               </a:rPr>
-              <a:t>weekly pipeline-cover ratio ≥3× next-quarter target; audit-led entry offers shorten hotel cycles to 2-4 months; order-book coverage reviewed monthly.
+              <a:t>we track pipeline cover weekly (at least 3x the next quarter's target); the audit entry offer keeps hotel cycles down to 2-4 months.
 </a:t>
             </a:r>
             <a:pPr indent="0" marL="0">
@@ -25514,7 +25514,7 @@
                 <a:ea typeface="Arial" pitchFamily="34" charset="-122"/>
                 <a:cs typeface="Arial" pitchFamily="34" charset="-120"/>
               </a:rPr>
-              <a:t>R8 Marquee-site failure (Reputation):  </a:t>
+              <a:t>R8 A big-name site fails (Reputation):  </a:t>
             </a:r>
             <a:pPr indent="0" marL="0">
               <a:lnSpc>
@@ -25531,7 +25531,7 @@
                 <a:ea typeface="Arial" pitchFamily="34" charset="-122"/>
                 <a:cs typeface="Arial" pitchFamily="34" charset="-120"/>
               </a:rPr>
-              <a:t>IoT uptime alerts on every AMC site, 48-hour response SLA, preventive-maintenance calendar, annual third-party NABL effluent audit at reference sites.</a:t>
+              <a:t>IoT uptime alerts on every AMC site, a 48-hour response promise, a preventive maintenance calendar, and a yearly NABL effluent audit at reference sites.</a:t>
             </a:r>
             <a:endParaRPr lang="en-US" sz="800" dirty="0"/>
           </a:p>
@@ -25626,7 +25626,7 @@
                 <a:ea typeface="Arial" pitchFamily="34" charset="-122"/>
                 <a:cs typeface="Arial" pitchFamily="34" charset="-120"/>
               </a:rPr>
-              <a:t>CONTROL   </a:t>
+              <a:t>IN SHORT   </a:t>
             </a:r>
             <a:pPr indent="0" marL="0">
               <a:lnSpc>
@@ -25635,7 +25635,7 @@
               <a:buNone/>
             </a:pPr>
             <a:r>
-              <a:rPr lang="en-US" sz="1150" b="1" dirty="0">
+              <a:rPr lang="en-US" sz="1100" b="1" dirty="0">
                 <a:solidFill>
                   <a:srgbClr val="FFFFFF"/>
                 </a:solidFill>
@@ -25643,7 +25643,7 @@
                 <a:ea typeface="Arial" pitchFamily="34" charset="-122"/>
                 <a:cs typeface="Arial" pitchFamily="34" charset="-120"/>
               </a:rPr>
-              <a:t>Milestone billing, exposure caps and gated expansion keep the plan self-funding; R7 and R8 stay on watch metrics.</a:t>
+              <a:t>Milestone billing, exposure caps and gated expansion keep the plan self-funding. R7 and R8 sit on watch metrics, not in the red zone.</a:t>
             </a:r>
             <a:endParaRPr lang="en-US" sz="1000" dirty="0"/>
           </a:p>
@@ -25893,7 +25893,7 @@
                 <a:ea typeface="Arial" pitchFamily="34" charset="-122"/>
                 <a:cs typeface="Arial" pitchFamily="34" charset="-120"/>
               </a:rPr>
-              <a:t>Rescue, monitor, recycle: </a:t>
+              <a:t>Three add-ons worth building, </a:t>
             </a:r>
             <a:pPr indent="0" marL="0">
               <a:buNone/>
@@ -25907,7 +25907,7 @@
                 <a:ea typeface="Arial" pitchFamily="34" charset="-122"/>
                 <a:cs typeface="Arial" pitchFamily="34" charset="-120"/>
               </a:rPr>
-              <a:t>sequence the adjacencies</a:t>
+              <a:t>in a set order</a:t>
             </a:r>
             <a:endParaRPr lang="en-US" sz="2500" dirty="0"/>
           </a:p>
@@ -26208,7 +26208,7 @@
                 <a:ea typeface="Arial" pitchFamily="34" charset="-122"/>
                 <a:cs typeface="Arial" pitchFamily="34" charset="-120"/>
               </a:rPr>
-              <a:t>demand 20 · synergy &amp; feasibility 20 · capital 15 (inverse) · margin 15 · complexity 10 (inverse) · time-to-market 10 · recurring 10 — scores 1-5, matrix p.9</a:t>
+              <a:t>demand 20 · synergy &amp; feasibility 20 · capital 15 (inverse) · margin 15 · complexity 10 (inverse) · time-to-market 10 · recurring 10. Scored 1 to 5; full matrix on p.9</a:t>
             </a:r>
             <a:endParaRPr lang="en-US" sz="680" dirty="0"/>
           </a:p>
@@ -26471,7 +26471,7 @@
                 <a:ea typeface="Arial" pitchFamily="34" charset="-122"/>
                 <a:cs typeface="Arial" pitchFamily="34" charset="-120"/>
               </a:rPr>
-              <a:t>CPCB 2021: a third of installed capacity idle/off-norm — certain demand, zero capex</a:t>
+              <a:t>CPCB found a third of installed capacity idle or off-norm, so demand is certain and capex is zero</a:t>
             </a:r>
             <a:endParaRPr lang="en-US" sz="640" dirty="0"/>
           </a:p>
@@ -26554,7 +26554,7 @@
                 <a:ea typeface="Arial" pitchFamily="34" charset="-122"/>
                 <a:cs typeface="Arial" pitchFamily="34" charset="-120"/>
               </a:rPr>
-              <a:t>₹3-15 L retrofit + ₹0.5-3 L/yr O&amp;M (~35% GM)</a:t>
+              <a:t>₹3-15 L per retrofit plus ₹0.5-3 L a year for O&amp;M (about 35% margin)</a:t>
             </a:r>
             <a:endParaRPr lang="en-US" sz="640" dirty="0"/>
           </a:p>
@@ -26720,7 +26720,7 @@
                 <a:ea typeface="Arial" pitchFamily="34" charset="-122"/>
                 <a:cs typeface="Arial" pitchFamily="34" charset="-120"/>
               </a:rPr>
-              <a:t>25 retrofits + 40 O&amp;M contracts by FY29; seeds AMC fleet</a:t>
+              <a:t>25 retrofits and 40 O&amp;M contracts by FY29; this also seeds the AMC fleet</a:t>
             </a:r>
             <a:endParaRPr lang="en-US" sz="640" dirty="0"/>
           </a:p>
@@ -26983,7 +26983,7 @@
                 <a:ea typeface="Arial" pitchFamily="34" charset="-122"/>
                 <a:cs typeface="Arial" pitchFamily="34" charset="-120"/>
               </a:rPr>
-              <a:t>Consent renewals demand data; differentiates every EPBL AMC</a:t>
+              <a:t>Consent renewals increasingly ask for data, and it makes every EPBL AMC harder to replace</a:t>
             </a:r>
             <a:endParaRPr lang="en-US" sz="640" dirty="0"/>
           </a:p>
@@ -27066,7 +27066,7 @@
                 <a:ea typeface="Arial" pitchFamily="34" charset="-122"/>
                 <a:cs typeface="Arial" pitchFamily="34" charset="-120"/>
               </a:rPr>
-              <a:t>₹10-15k install + ₹3-5k/month per site; ₹50-70 L invest</a:t>
+              <a:t>₹10-15k to install plus ₹3-5k a month per site; ₹50-70 L to set up</a:t>
             </a:r>
             <a:endParaRPr lang="en-US" sz="640" dirty="0"/>
           </a:p>
@@ -27232,7 +27232,7 @@
                 <a:ea typeface="Arial" pitchFamily="34" charset="-122"/>
                 <a:cs typeface="Arial" pitchFamily="34" charset="-120"/>
               </a:rPr>
-              <a:t>150 connected sites by FY29, churn &lt;10%</a:t>
+              <a:t>150 connected sites by FY29, with churn under 10%</a:t>
             </a:r>
             <a:endParaRPr lang="en-US" sz="640" dirty="0"/>
           </a:p>
@@ -27495,7 +27495,7 @@
                 <a:ea typeface="Arial" pitchFamily="34" charset="-122"/>
                 <a:cs typeface="Arial" pitchFamily="34" charset="-120"/>
               </a:rPr>
-              <a:t>Hotels pay tanker rates for water CGWA tells them to recycle; builds on oxy-STP + IISc MoU</a:t>
+              <a:t>Hotels pay tanker rates for water that CGWA already tells them to recycle; builds on the oxy-STP line and the IISc MoU</a:t>
             </a:r>
             <a:endParaRPr lang="en-US" sz="640" dirty="0"/>
           </a:p>
@@ -27578,7 +27578,7 @@
                 <a:ea typeface="Arial" pitchFamily="34" charset="-122"/>
                 <a:cs typeface="Arial" pitchFamily="34" charset="-120"/>
               </a:rPr>
-              <a:t>₹6-18 L add-on skid (UF + carbon + UV/O3); ₹1-1.5 cr dev</a:t>
+              <a:t>₹6-18 L add-on skid (UF, carbon, UV/ozone); ₹1-1.5 cr to develop</a:t>
             </a:r>
             <a:endParaRPr lang="en-US" sz="640" dirty="0"/>
           </a:p>
@@ -27661,7 +27661,7 @@
                 <a:ea typeface="Arial" pitchFamily="34" charset="-122"/>
                 <a:cs typeface="Arial" pitchFamily="34" charset="-120"/>
               </a:rPr>
-              <a:t>2 Goa resorts + 1 Kolhapur society</a:t>
+              <a:t>2 Goa resorts and 1 Kolhapur society</a:t>
             </a:r>
             <a:endParaRPr lang="en-US" sz="640" dirty="0"/>
           </a:p>
@@ -27744,7 +27744,7 @@
                 <a:ea typeface="Arial" pitchFamily="34" charset="-122"/>
                 <a:cs typeface="Arial" pitchFamily="34" charset="-120"/>
               </a:rPr>
-              <a:t>Attached to 25% of new STP orders by FY29</a:t>
+              <a:t>On 25% of new STP orders by FY29</a:t>
             </a:r>
             <a:endParaRPr lang="en-US" sz="640" dirty="0"/>
           </a:p>
@@ -28404,7 +28404,7 @@
                 <a:ea typeface="Arial" pitchFamily="34" charset="-122"/>
                 <a:cs typeface="Arial" pitchFamily="34" charset="-120"/>
               </a:rPr>
-              <a:t>Deferred: full WaaS/BOOT (partner-financed pilot only), MBR premium line, FSTP, biogas — capex, municipal dependence or sub-scale economics. Combined: ~₹2.4 cr/yr recurring by FY29 at 35-40% GM.</a:t>
+              <a:t>Parked for now: full WaaS (partner-financed pilot only), an MBR line, FSTP and biogas. Too much capex, too municipal, or too small. The three we picked add about ₹2.4 cr a year of recurring revenue by FY29 at 35-40% margins.</a:t>
             </a:r>
             <a:endParaRPr lang="en-US" sz="700" dirty="0"/>
           </a:p>
@@ -28499,7 +28499,7 @@
                 <a:ea typeface="Arial" pitchFamily="34" charset="-122"/>
                 <a:cs typeface="Arial" pitchFamily="34" charset="-120"/>
               </a:rPr>
-              <a:t>THESIS   </a:t>
+              <a:t>BOTTOM LINE   </a:t>
             </a:r>
             <a:pPr indent="0" marL="0">
               <a:lnSpc>
@@ -28508,7 +28508,7 @@
               <a:buNone/>
             </a:pPr>
             <a:r>
-              <a:rPr lang="en-US" sz="1100" b="1" dirty="0">
+              <a:rPr lang="en-US" sz="1050" b="1" dirty="0">
                 <a:solidFill>
                   <a:srgbClr val="FFFFFF"/>
                 </a:solidFill>
@@ -28516,7 +28516,7 @@
                 <a:ea typeface="Arial" pitchFamily="34" charset="-122"/>
                 <a:cs typeface="Arial" pitchFamily="34" charset="-120"/>
               </a:rPr>
-              <a:t>Each adjacency deepens the installed base and lifts recurring revenue to ~10% of sales by FY29 — no new manufacturing needed.</a:t>
+              <a:t>The add-ons sell into plants we already service and lift recurring revenue to about 10% of sales by FY29, with no new manufacturing.</a:t>
             </a:r>
             <a:endParaRPr lang="en-US" sz="1000" dirty="0"/>
           </a:p>
@@ -29609,7 +29609,7 @@
                 <a:cs typeface="Arial" pitchFamily="34" charset="-120"/>
               </a:rPr>
               <a:t>
-Sizing: bottom-up per segment per state — units × %lacking × fit × conversion × ticket. No top-down report allocation.
+Sizing: bottom-up per segment per state, as units x share lacking treatment x fit x conversion x ticket. No top-down report allocation.
 </a:t>
             </a:r>
             <a:pPr indent="0" marL="0">
@@ -43059,7 +43059,7 @@
                 <a:ea typeface="Arial" pitchFamily="34" charset="-122"/>
                 <a:cs typeface="Arial" pitchFamily="34" charset="-120"/>
               </a:rPr>
-              <a:t>75 DSO → ₹5.2 cr receivables vs net worth &gt;₹12 cr + IPO WC.  </a:t>
+              <a:t>at 75 receivable days that is ₹5.2 cr locked up, against net worth above ₹12 cr plus IPO working capital.  </a:t>
             </a:r>
             <a:pPr indent="0" marL="0">
               <a:lnSpc>

</xml_diff>